<commit_message>
docs: relatório e slides com screenshots do novo visual (sidebar)
Recaptura as figuras do app (Simulador, base de conhecimento, diagnóstico e
traço de inferência) no design atual e regenera o .docx (14 páginas) e o .pptx.

Co-Authored-By: Claude Opus 4.8 <noreply@anthropic.com>
</commit_message>
<xml_diff>
--- a/outputs/apresentacao-ruledesk.pptx
+++ b/outputs/apresentacao-ruledesk.pptx
@@ -2616,11 +2616,11 @@
         <p:spPr>
           <a:xfrm>
             <a:off x="457200" y="2011680"/>
-            <a:ext cx="6803136" cy="3941767"/>
+            <a:ext cx="6163056" cy="4206017"/>
           </a:xfrm>
           <a:prstGeom prst="roundRect">
             <a:avLst>
-              <a:gd name="adj" fmla="val 2320"/>
+              <a:gd name="adj" fmla="val 2174"/>
             </a:avLst>
           </a:prstGeom>
           <a:solidFill>
@@ -2658,7 +2658,7 @@
         <p:spPr>
           <a:xfrm>
             <a:off x="566928" y="2121408"/>
-            <a:ext cx="6583680" cy="3722311"/>
+            <a:ext cx="5943600" cy="3986561"/>
           </a:xfrm>
           <a:prstGeom prst="rect">
             <a:avLst/>
@@ -2673,8 +2673,8 @@
         </p:nvSpPr>
         <p:spPr>
           <a:xfrm>
-            <a:off x="7653528" y="2194560"/>
-            <a:ext cx="3971239" cy="3200400"/>
+            <a:off x="7013448" y="2194560"/>
+            <a:ext cx="4611319" cy="3200400"/>
           </a:xfrm>
           <a:prstGeom prst="rect">
             <a:avLst/>
@@ -3259,12 +3259,12 @@
         </p:nvSpPr>
         <p:spPr>
           <a:xfrm>
-            <a:off x="6225414" y="548640"/>
-            <a:ext cx="5435929" cy="6163056"/>
+            <a:off x="7144107" y="548640"/>
+            <a:ext cx="4517236" cy="6163056"/>
           </a:xfrm>
           <a:prstGeom prst="roundRect">
             <a:avLst>
-              <a:gd name="adj" fmla="val 1682"/>
+              <a:gd name="adj" fmla="val 2024"/>
             </a:avLst>
           </a:prstGeom>
           <a:solidFill>
@@ -3301,8 +3301,8 @@
         </p:blipFill>
         <p:spPr>
           <a:xfrm>
-            <a:off x="6353430" y="658368"/>
-            <a:ext cx="5179897" cy="5943600"/>
+            <a:off x="7272123" y="658368"/>
+            <a:ext cx="4261204" cy="5943600"/>
           </a:xfrm>
           <a:prstGeom prst="rect">
             <a:avLst/>
@@ -10556,12 +10556,12 @@
         </p:nvSpPr>
         <p:spPr>
           <a:xfrm>
-            <a:off x="8466346" y="1828800"/>
-            <a:ext cx="2500053" cy="4572000"/>
+            <a:off x="8765446" y="1828800"/>
+            <a:ext cx="2200953" cy="4572000"/>
           </a:xfrm>
           <a:prstGeom prst="roundRect">
             <a:avLst>
-              <a:gd name="adj" fmla="val 3658"/>
+              <a:gd name="adj" fmla="val 4155"/>
             </a:avLst>
           </a:prstGeom>
           <a:solidFill>
@@ -10598,8 +10598,8 @@
         </p:blipFill>
         <p:spPr>
           <a:xfrm>
-            <a:off x="8630938" y="1965960"/>
-            <a:ext cx="2170869" cy="4297680"/>
+            <a:off x="8930038" y="1965960"/>
+            <a:ext cx="1871769" cy="4297680"/>
           </a:xfrm>
           <a:prstGeom prst="rect">
             <a:avLst/>
@@ -10841,8 +10841,8 @@
         </p:nvSpPr>
         <p:spPr>
           <a:xfrm>
-            <a:off x="1978725" y="2395728"/>
-            <a:ext cx="8234246" cy="3941064"/>
+            <a:off x="2707988" y="2395728"/>
+            <a:ext cx="6775718" cy="3941064"/>
           </a:xfrm>
           <a:prstGeom prst="roundRect">
             <a:avLst>
@@ -10883,8 +10883,8 @@
         </p:blipFill>
         <p:spPr>
           <a:xfrm>
-            <a:off x="2106741" y="2505456"/>
-            <a:ext cx="7978214" cy="3703320"/>
+            <a:off x="2836004" y="2505456"/>
+            <a:ext cx="6519686" cy="3703320"/>
           </a:xfrm>
           <a:prstGeom prst="rect">
             <a:avLst/>

</xml_diff>